<commit_message>
Lesson 1 and Lesson 2 Slides updated
</commit_message>
<xml_diff>
--- a/Python/Lesson 01 - Python Basics/Lesson 1  - Intro to Python.pptx
+++ b/Python/Lesson 01 - Python Basics/Lesson 1  - Intro to Python.pptx
@@ -41056,7 +41056,7 @@
             </a:pPr>
             <a:r>
               <a:rPr lang="en-US" dirty="0"/>
-              <a:t>MORE INFORMATION ABOU THE PRINT FUNCTION</a:t>
+              <a:t>MORE INFORMATION ABOUT THE PRINT FUNCTION</a:t>
             </a:r>
           </a:p>
         </p:txBody>
@@ -41508,7 +41508,7 @@
             </a:pPr>
             <a:r>
               <a:rPr lang="en-US" dirty="0"/>
-              <a:t>MORE INFORMATION ABOU THE PRINT FUNCTION</a:t>
+              <a:t>MORE INFORMATION ABOUT THE PRINT FUNCTION</a:t>
             </a:r>
           </a:p>
         </p:txBody>
@@ -43135,7 +43135,7 @@
         <p:spPr>
           <a:xfrm>
             <a:off x="411480" y="1200149"/>
-            <a:ext cx="8268694" cy="3429000"/>
+            <a:ext cx="8268694" cy="3817900"/>
           </a:xfrm>
           <a:noFill/>
           <a:ln>
@@ -43144,63 +43144,73 @@
         </p:spPr>
         <p:txBody>
           <a:bodyPr spcFirstLastPara="1" wrap="square" lIns="91425" tIns="45700" rIns="91425" bIns="45700" anchor="t" anchorCtr="0">
-            <a:normAutofit/>
+            <a:normAutofit fontScale="85000" lnSpcReduction="10000"/>
           </a:bodyPr>
           <a:lstStyle/>
           <a:p>
+            <a:pPr lvl="0"/>
+            <a:r>
+              <a:rPr lang="en-US" sz="1900" dirty="0"/>
+              <a:t>Write a script that prompts the user for a diameter of the pizza and outputs the area</a:t>
+            </a:r>
+          </a:p>
+          <a:p>
+            <a:pPr lvl="0"/>
+            <a:endParaRPr lang="en-US" sz="1900" dirty="0"/>
+          </a:p>
+          <a:p>
+            <a:pPr lvl="0"/>
+            <a:r>
+              <a:rPr lang="en-US" sz="1900" dirty="0"/>
+              <a:t>Remember to convert from string to another datatype</a:t>
+            </a:r>
+          </a:p>
+          <a:p>
+            <a:pPr lvl="0"/>
+            <a:endParaRPr lang="en-US" sz="1900" dirty="0"/>
+          </a:p>
+          <a:p>
+            <a:pPr lvl="0"/>
+            <a:r>
+              <a:rPr lang="en-US" sz="1900" dirty="0"/>
+              <a:t>Stretch goal #1:  write a script that calculates the price per area.  The user should input the diameter and the cost.</a:t>
+            </a:r>
+          </a:p>
+          <a:p>
+            <a:pPr lvl="0"/>
+            <a:endParaRPr lang="en-US" sz="1900" dirty="0"/>
+          </a:p>
+          <a:p>
+            <a:pPr lvl="0"/>
+            <a:r>
+              <a:rPr lang="en-US" sz="1900" dirty="0"/>
+              <a:t>Stretch goal #2:  write a script that calculates the best deal.  </a:t>
+            </a:r>
+          </a:p>
+          <a:p>
             <a:pPr marL="0" lvl="0" indent="0">
               <a:buNone/>
             </a:pPr>
-            <a:endParaRPr lang="en-US" dirty="0"/>
+            <a:r>
+              <a:rPr lang="en-US" sz="1900" dirty="0"/>
+              <a:t>The deal is 2 pizzas of one size compared to 1 pizza of another size.</a:t>
+            </a:r>
+            <a:br>
+              <a:rPr lang="en-US" sz="1900" dirty="0"/>
+            </a:br>
+            <a:r>
+              <a:rPr lang="en-US" sz="1900" dirty="0"/>
+              <a:t>The user should input two diameters (one for the first deal, one for the second deal), and the two costs.</a:t>
+            </a:r>
           </a:p>
           <a:p>
             <a:pPr lvl="0"/>
-            <a:r>
-              <a:rPr lang="en-US" dirty="0"/>
-              <a:t>Write a script that prompts the user for a diameter of the pizza and outputs the area</a:t>
-            </a:r>
+            <a:endParaRPr lang="en-US" sz="1900" dirty="0"/>
           </a:p>
           <a:p>
             <a:pPr lvl="0"/>
-            <a:endParaRPr lang="en-US" dirty="0"/>
-          </a:p>
-          <a:p>
-            <a:pPr lvl="0"/>
-            <a:r>
-              <a:rPr lang="en-US" dirty="0"/>
-              <a:t>Remember to convert from string to another datatype</a:t>
-            </a:r>
-          </a:p>
-          <a:p>
-            <a:pPr lvl="0"/>
-            <a:endParaRPr lang="en-US" dirty="0"/>
-          </a:p>
-          <a:p>
-            <a:pPr lvl="0"/>
-            <a:r>
-              <a:rPr lang="en-US" dirty="0"/>
-              <a:t>Stretch goal #1:  write a script that calculates the price per area.  The user should input the diameter and the cost.</a:t>
-            </a:r>
-          </a:p>
-          <a:p>
-            <a:pPr lvl="0"/>
-            <a:endParaRPr lang="en-US" dirty="0"/>
-          </a:p>
-          <a:p>
-            <a:pPr lvl="0"/>
-            <a:r>
-              <a:rPr lang="en-US" dirty="0"/>
-              <a:t>Stretch goal #2:  write a script that calculates the best deal.  The user should input three diameters (two for the first deal, one for the second deal), and the two costs.</a:t>
-            </a:r>
-          </a:p>
-          <a:p>
-            <a:pPr lvl="0"/>
-            <a:endParaRPr lang="en-US" dirty="0"/>
-          </a:p>
-          <a:p>
-            <a:pPr lvl="0"/>
-            <a:r>
-              <a:rPr lang="en-US" dirty="0"/>
+            <a:r>
+              <a:rPr lang="en-US" sz="1900" dirty="0"/>
               <a:t>Solutions available in the lesson folder</a:t>
             </a:r>
           </a:p>
@@ -44197,32 +44207,27 @@
           <a:lstStyle/>
           <a:p>
             <a:r>
-              <a:rPr lang="en-US" dirty="0"/>
+              <a:rPr lang="en-US" sz="2000" dirty="0"/>
               <a:t>Pull changes from the summer-courses remote repo to your version of the remote repo</a:t>
             </a:r>
           </a:p>
           <a:p>
-            <a:endParaRPr lang="en-US" dirty="0"/>
-          </a:p>
-          <a:p>
-            <a:r>
-              <a:rPr lang="en-US" dirty="0"/>
+            <a:endParaRPr lang="en-US" sz="2000" dirty="0"/>
+          </a:p>
+          <a:p>
+            <a:r>
+              <a:rPr lang="en-US" sz="2000" dirty="0"/>
               <a:t>Pull those changes locally</a:t>
             </a:r>
           </a:p>
           <a:p>
-            <a:endParaRPr lang="en-US" dirty="0"/>
-          </a:p>
-          <a:p>
-            <a:r>
-              <a:rPr lang="en-US" dirty="0"/>
-              <a:t>Create a notes file in the lesson one folder… </a:t>
-            </a:r>
-            <a:r>
-              <a:rPr lang="en-US"/>
-              <a:t>I recommend ‘lesson1_notes.py’</a:t>
-            </a:r>
-            <a:endParaRPr lang="en-US" dirty="0"/>
+            <a:endParaRPr lang="en-US" sz="2000" dirty="0"/>
+          </a:p>
+          <a:p>
+            <a:r>
+              <a:rPr lang="en-US" sz="2000" dirty="0"/>
+              <a:t>Create a notes file in the lesson one folder… I recommend ‘lesson1_notes.py’, commit and push that to your remote repo</a:t>
+            </a:r>
           </a:p>
         </p:txBody>
       </p:sp>

</xml_diff>